<commit_message>
Two wording fixes: slide 3 execution question, slide 7 duplicate note
  3  proof[4].q rewritten to "מה צריך להיות סגור לפני שמתחילים לפתח?" and
     "מי מוביל, מהי חלוקת התפקידים, אילו משאבים נדרשים ומהן אבני הדרך
     הנדרשות?" — "חלוקת התפקידים" in place of "בעלות", and the "אבני הדרך
     הנדרשות" plural agreement fixed
  7  the navy band no longer repeats "התעריף זהה בשני המסלולים" — that
     sentence now lives only in the slide's subtitle. commercial.rate_note_he
     and the .rate-n rule are removed outright rather than left unused.

No other wording, color, layout, typography, methodology, numbers or slide
order touched. Typography stays Heebo in the render; the PPTX font mapping is
untouched per this round's instruction.

QA: 8 slides, 0 issues, figures verified, 0 blocks at risk of spilling in
Arial. Slides 3 and 7 checked side by side against the rendered PPTX.
</commit_message>
<xml_diff>
--- a/dist/deck.pptx
+++ b/dist/deck.pptx
@@ -6584,7 +6584,7 @@
                 <a:ea typeface="Arial"/>
                 <a:cs typeface="Arial"/>
               </a:rPr>
-              <a:t>מה צריך לקרות לפני פיתוח?</a:t>
+              <a:t>מה צריך להיות סגור לפני שמתחילים לפתח?</a:t>
             </a:r>
           </a:p>
         </p:txBody>
@@ -6625,7 +6625,7 @@
                 <a:ea typeface="Arial"/>
                 <a:cs typeface="Arial"/>
               </a:rPr>
-              <a:t>אילו משאבים, בעלוּת ואבני דרך נדרשים?</a:t>
+              <a:t>מי מוביל, מהי חלוקת התפקידים, אילו משאבים נדרשים ומהן אבני הדרך הנדרשות?</a:t>
             </a:r>
           </a:p>
         </p:txBody>
@@ -12550,48 +12550,7 @@
       </p:sp>
       <p:sp>
         <p:nvSpPr>
-          <p:cNvPr id="12" name="TextBox 11"/>
-          <p:cNvSpPr txBox="1"/>
-          <p:nvPr/>
-        </p:nvSpPr>
-        <p:spPr>
-          <a:xfrm>
-            <a:off x="639858" y="2749550"/>
-            <a:ext cx="2122392" cy="222250"/>
-          </a:xfrm>
-          <a:prstGeom prst="rect">
-            <a:avLst/>
-          </a:prstGeom>
-          <a:noFill/>
-        </p:spPr>
-        <p:txBody>
-          <a:bodyPr wrap="square" lIns="0" rIns="0" tIns="0" bIns="0" anchor="t">
-            <a:noAutofit/>
-          </a:bodyPr>
-          <a:lstStyle/>
-          <a:p>
-            <a:pPr algn="r" rtl="1">
-              <a:lnSpc>
-                <a:spcPts val="1440"/>
-              </a:lnSpc>
-            </a:pPr>
-            <a:r>
-              <a:rPr sz="1200" b="0">
-                <a:solidFill>
-                  <a:srgbClr val="FFFFFF"/>
-                </a:solidFill>
-                <a:latin typeface="Arial"/>
-                <a:ea typeface="Arial"/>
-                <a:cs typeface="Arial"/>
-              </a:rPr>
-              <a:t>התעריף זהה בשני המסלולים.</a:t>
-            </a:r>
-          </a:p>
-        </p:txBody>
-      </p:sp>
-      <p:sp>
-        <p:nvSpPr>
-          <p:cNvPr id="13" name="Rectangle 12"/>
+          <p:cNvPr id="12" name="Rectangle 11"/>
           <p:cNvSpPr/>
           <p:nvPr/>
         </p:nvSpPr>
@@ -12623,7 +12582,7 @@
       </p:sp>
       <p:sp>
         <p:nvSpPr>
-          <p:cNvPr id="14" name="Rectangle 13"/>
+          <p:cNvPr id="13" name="Rectangle 12"/>
           <p:cNvSpPr/>
           <p:nvPr/>
         </p:nvSpPr>
@@ -12655,7 +12614,7 @@
       </p:sp>
       <p:sp>
         <p:nvSpPr>
-          <p:cNvPr id="15" name="Rectangle 14"/>
+          <p:cNvPr id="14" name="Rectangle 13"/>
           <p:cNvSpPr/>
           <p:nvPr/>
         </p:nvSpPr>
@@ -12687,7 +12646,7 @@
       </p:sp>
       <p:sp>
         <p:nvSpPr>
-          <p:cNvPr id="16" name="Rectangle 15"/>
+          <p:cNvPr id="15" name="Rectangle 14"/>
           <p:cNvSpPr/>
           <p:nvPr/>
         </p:nvSpPr>
@@ -12719,7 +12678,7 @@
       </p:sp>
       <p:sp>
         <p:nvSpPr>
-          <p:cNvPr id="17" name="Rectangle 16"/>
+          <p:cNvPr id="16" name="Rectangle 15"/>
           <p:cNvSpPr/>
           <p:nvPr/>
         </p:nvSpPr>
@@ -12751,7 +12710,7 @@
       </p:sp>
       <p:sp>
         <p:nvSpPr>
-          <p:cNvPr id="18" name="Rectangle 17"/>
+          <p:cNvPr id="17" name="Rectangle 16"/>
           <p:cNvSpPr/>
           <p:nvPr/>
         </p:nvSpPr>
@@ -12783,7 +12742,7 @@
       </p:sp>
       <p:sp>
         <p:nvSpPr>
-          <p:cNvPr id="19" name="TextBox 18"/>
+          <p:cNvPr id="18" name="TextBox 17"/>
           <p:cNvSpPr txBox="1"/>
           <p:nvPr/>
         </p:nvSpPr>
@@ -12824,7 +12783,7 @@
       </p:sp>
       <p:sp>
         <p:nvSpPr>
-          <p:cNvPr id="20" name="TextBox 19"/>
+          <p:cNvPr id="19" name="TextBox 18"/>
           <p:cNvSpPr txBox="1"/>
           <p:nvPr/>
         </p:nvSpPr>
@@ -12865,7 +12824,7 @@
       </p:sp>
       <p:sp>
         <p:nvSpPr>
-          <p:cNvPr id="21" name="TextBox 20"/>
+          <p:cNvPr id="20" name="TextBox 19"/>
           <p:cNvSpPr txBox="1"/>
           <p:nvPr/>
         </p:nvSpPr>
@@ -12928,7 +12887,7 @@
       </p:sp>
       <p:sp>
         <p:nvSpPr>
-          <p:cNvPr id="22" name="TextBox 21"/>
+          <p:cNvPr id="21" name="TextBox 20"/>
           <p:cNvSpPr txBox="1"/>
           <p:nvPr/>
         </p:nvSpPr>
@@ -12969,7 +12928,7 @@
       </p:sp>
       <p:sp>
         <p:nvSpPr>
-          <p:cNvPr id="23" name="Rectangle 22"/>
+          <p:cNvPr id="22" name="Rectangle 21"/>
           <p:cNvSpPr/>
           <p:nvPr/>
         </p:nvSpPr>
@@ -13001,7 +12960,7 @@
       </p:sp>
       <p:sp>
         <p:nvSpPr>
-          <p:cNvPr id="24" name="Rectangle 23"/>
+          <p:cNvPr id="23" name="Rectangle 22"/>
           <p:cNvSpPr/>
           <p:nvPr/>
         </p:nvSpPr>
@@ -13033,7 +12992,7 @@
       </p:sp>
       <p:sp>
         <p:nvSpPr>
-          <p:cNvPr id="25" name="Rectangle 24"/>
+          <p:cNvPr id="24" name="Rectangle 23"/>
           <p:cNvSpPr/>
           <p:nvPr/>
         </p:nvSpPr>
@@ -13065,7 +13024,7 @@
       </p:sp>
       <p:sp>
         <p:nvSpPr>
-          <p:cNvPr id="26" name="Rectangle 25"/>
+          <p:cNvPr id="25" name="Rectangle 24"/>
           <p:cNvSpPr/>
           <p:nvPr/>
         </p:nvSpPr>
@@ -13097,7 +13056,7 @@
       </p:sp>
       <p:sp>
         <p:nvSpPr>
-          <p:cNvPr id="27" name="Rectangle 26"/>
+          <p:cNvPr id="26" name="Rectangle 25"/>
           <p:cNvSpPr/>
           <p:nvPr/>
         </p:nvSpPr>
@@ -13129,7 +13088,7 @@
       </p:sp>
       <p:sp>
         <p:nvSpPr>
-          <p:cNvPr id="28" name="Rectangle 27"/>
+          <p:cNvPr id="27" name="Rectangle 26"/>
           <p:cNvSpPr/>
           <p:nvPr/>
         </p:nvSpPr>
@@ -13161,7 +13120,7 @@
       </p:sp>
       <p:sp>
         <p:nvSpPr>
-          <p:cNvPr id="29" name="TextBox 28"/>
+          <p:cNvPr id="28" name="TextBox 27"/>
           <p:cNvSpPr txBox="1"/>
           <p:nvPr/>
         </p:nvSpPr>
@@ -13202,7 +13161,7 @@
       </p:sp>
       <p:sp>
         <p:nvSpPr>
-          <p:cNvPr id="30" name="TextBox 29"/>
+          <p:cNvPr id="29" name="TextBox 28"/>
           <p:cNvSpPr txBox="1"/>
           <p:nvPr/>
         </p:nvSpPr>
@@ -13243,7 +13202,7 @@
       </p:sp>
       <p:sp>
         <p:nvSpPr>
-          <p:cNvPr id="31" name="TextBox 30"/>
+          <p:cNvPr id="30" name="TextBox 29"/>
           <p:cNvSpPr txBox="1"/>
           <p:nvPr/>
         </p:nvSpPr>
@@ -13284,7 +13243,7 @@
       </p:sp>
       <p:sp>
         <p:nvSpPr>
-          <p:cNvPr id="32" name="TextBox 31"/>
+          <p:cNvPr id="31" name="TextBox 30"/>
           <p:cNvSpPr txBox="1"/>
           <p:nvPr/>
         </p:nvSpPr>
@@ -13325,7 +13284,7 @@
       </p:sp>
       <p:sp>
         <p:nvSpPr>
-          <p:cNvPr id="33" name="Rectangle 32"/>
+          <p:cNvPr id="32" name="Rectangle 31"/>
           <p:cNvSpPr/>
           <p:nvPr/>
         </p:nvSpPr>
@@ -13357,7 +13316,7 @@
       </p:sp>
       <p:sp>
         <p:nvSpPr>
-          <p:cNvPr id="34" name="Rectangle 33"/>
+          <p:cNvPr id="33" name="Rectangle 32"/>
           <p:cNvSpPr/>
           <p:nvPr/>
         </p:nvSpPr>
@@ -13389,7 +13348,7 @@
       </p:sp>
       <p:sp>
         <p:nvSpPr>
-          <p:cNvPr id="35" name="TextBox 34"/>
+          <p:cNvPr id="34" name="TextBox 33"/>
           <p:cNvSpPr txBox="1"/>
           <p:nvPr/>
         </p:nvSpPr>
@@ -13452,7 +13411,7 @@
       </p:sp>
       <p:sp>
         <p:nvSpPr>
-          <p:cNvPr id="36" name="Rectangle 35"/>
+          <p:cNvPr id="35" name="Rectangle 34"/>
           <p:cNvSpPr/>
           <p:nvPr/>
         </p:nvSpPr>
@@ -13484,7 +13443,7 @@
       </p:sp>
       <p:sp>
         <p:nvSpPr>
-          <p:cNvPr id="37" name="TextBox 36"/>
+          <p:cNvPr id="36" name="TextBox 35"/>
           <p:cNvSpPr txBox="1"/>
           <p:nvPr/>
         </p:nvSpPr>
@@ -13525,7 +13484,7 @@
       </p:sp>
       <p:sp>
         <p:nvSpPr>
-          <p:cNvPr id="38" name="TextBox 37"/>
+          <p:cNvPr id="37" name="TextBox 36"/>
           <p:cNvSpPr txBox="1"/>
           <p:nvPr/>
         </p:nvSpPr>

</xml_diff>